<commit_message>
Ajoute le PDF de la presentation et signale les captures perimees
`docs/Presentation_methode_Kenza.pdf` : 21 diapositives, produit par LibreOffice
depuis le .pptx. Verifie sans residu de date, d'auditoire ni d'adresse.

En relisant le rendu, une contradiction sautait aux yeux sur deux diapositives :
le texte porte les noms corriges (kenza_k1, curve_c) et les chiffres recalcules,
tandis que la capture d'ecran a cote montre encore full_penetration,
full_price_scale, k1 et les anciennes valeurs — avec, au passage, la precision a
deux decimales que la branche a corrigee (0.82 pour 0,8193343775346827).

Refaire ces captures demande un serveur graphique, dont je ne dispose pas. Les
diapositives 13 et 14 le disent donc explicitement plutot que de laisser le
lecteur trancher entre deux versions affichees cote a cote.

Co-Authored-By: Claude Opus 5 <noreply@anthropic.com>
Claude-Session: https://claude.ai/code/session_0198V6kWVNKyFFiPCBcmLXVg
</commit_message>
<xml_diff>
--- a/docs/Presentation_methode_Kenza.pptx
+++ b/docs/Presentation_methode_Kenza.pptx
@@ -10776,7 +10776,7 @@
                 <a:cs typeface="Arial"/>
                 <a:sym typeface="Arial"/>
               </a:rPr>
-              <a:t>Paramètres modifiables</a:t>
+              <a:t>Paramètres modifiables — noms actuels ; la capture ci-contre montre les anciens</a:t>
             </a:r>
             <a:endParaRPr b="0" i="0" sz="1500" u="none" cap="none" strike="noStrike">
               <a:solidFill>
@@ -11146,7 +11146,7 @@
                 <a:cs typeface="Arial"/>
                 <a:sym typeface="Arial"/>
               </a:rPr>
-              <a:t>Métrique de performance</a:t>
+              <a:t>Métriques recalculées — la capture ci-contre date de la version antérieure</a:t>
             </a:r>
             <a:endParaRPr b="0" i="0" sz="1500" u="none" cap="none" strike="noStrike">
               <a:solidFill>

</xml_diff>